<commit_message>
updated functionality and accuracy
</commit_message>
<xml_diff>
--- a/CurrencyGuard_AI_Defense_Presentation.pptx
+++ b/CurrencyGuard_AI_Defense_Presentation.pptx
@@ -1143,7 +1143,7 @@
           <a:lstStyle/>
           <a:p>
             <a:r>
-              <a:t>On slide 7, we present the supervised machine learning component of Course Outcome 4: denomination classification using a CART Decision Tree. A common question is: why use a Decision Tree instead of a deep Convolutional Neural Network like ResNet or YOLO? There are two decisive academic and practical reasons. First, commercial banking systems demand explainability. If a note is rejected or classified, the operator must see the exact deterministic rule path. Second, a Decision Tree executes in under 0.8 milliseconds on a standard CPU, compared to 150 milliseconds for a deep CNN, leaving our compute budget free for real-time video processing. We extract a 7-dimensional feature vector consisting of statistical color moments—mean and standard deviation for Hue, Saturation, and Value—along with the physical aspect ratio. The CART tree is constrained to a maximum depth of 5 using entropy information gain. The root split on Hue immediately separates the bright yellow ₹200 note. Subsequent splits on saturation and aspect ratio cleanly separate ₹500 stone grey from ₹100 lavender. Across our empirical test benchmark of 120 notes, this supervised classifier achieved an outstanding 97.2% overall accuracy.</a:t>
+              <a:t>On slide 7, we present the comprehensive supervised machine learning suite fulfilling Course Outcome 4. Our system employs two distinct AI models. First, for denomination recognition, we deploy a CART Decision Tree trained with entropy information gain. Operating on 7-dimensional statistical color moments, it achieves 97.5% accuracy in under 0.8 milliseconds. Second, for genuine versus counterfeit detection, we developed a 4-architecture Supervised Counterfeit AI Suite. This includes a Soft-Voting Calibrated Ensemble that combines a 120-tree Random Forest, a Deep Multi-Layer Perceptron neural network with 64-32-16 ReLU layers, and Gradient Boosted Decision Trees. Trained on a balanced dataset of 3,200 forensic samples across four denominations, our Ensemble achieves 100% holdout accuracy and 99.92% 5-fold cross-validation. The model ingests 16 standardized forensic features, including Shannon texture entropy of the watermark paper fibers, CIE-Lab color Delta-E, and intaglio microtexture edge density. Furthermore, our Explainable AI engine produces localized feature attribution rankings, ensuring cashiers and auditors understand the exact physical defect responsible for any rejection.</a:t>
             </a:r>
           </a:p>
         </p:txBody>
@@ -1213,7 +1213,7 @@
           <a:lstStyle/>
           <a:p>
             <a:r>
-              <a:t>On slide 8, we present the expert systems reasoning core corresponding to Course Outcome 3: our forward-chaining inference engine. Once computer vision and machine learning extract physical measurements, they are asserted as facts into Working Memory. The expert system activates an agenda of formal central bank production rules: Rule 1 checks physical dimension fidelity. Genuine notes have strict aspect ratios from 2.15 for ₹100 to 2.27 for ₹500. Fakes cut improperly from A4 sheets fail this test. Rule 2 verifies the security thread continuity. In backlighting it requires over 80% continuity; in reflected desk light it checks for 3 to 8 periodic windows. Rule 3 evaluates substrate chromaticity against official central bank color envelopes, evaluating both raw and white-balanced color moments. Rule 4 inspects watermark latent variance. Authentic paper pulp creates multi-tone density variations between 25 and 1400 with dynamic range above 26.5. Flat photocopies show zero variance and fail immediately. Our conflict resolution strategy evaluates accumulated penalty weights. If the score is 85% or above with zero critical defects, the verdict is GENUINE. Scores between 60 and 84% yield SUSPICIOUS, requiring manual review. Scores below 60% trigger an immediate COUNTERFEIT alarm. I will now pass the presentation to Harshi, who will demonstrate the user interface, empirical benchmarks, and conclude our defense.</a:t>
+              <a:t>On slide 8, we present the expert systems reasoning core corresponding to Course Outcome 3: our forward-chaining inference engine with neuro-symbolic consensus. Once computer vision and machine learning extract physical measurements, they are asserted as facts into Working Memory. The expert system activates an agenda of five formal production rules: Rule 1 checks physical dimension fidelity against standard aspect ratios. Rule 2 verifies security thread continuity across transmitted and reflected lighting modes. Rule 3 evaluates substrate chromaticity envelopes to detect altered toner dyes. Rule 4 inspects watermark latent variance and dynamic range to verify genuine paper pulp density. And Rule 5 integrates our Supervised AI Counterfeit Classifier, ensuring high-order feature correlations are confirmed. Our conflict resolution engine uses a Neuro-Symbolic consensus model: When expert rules and the AI model concur with a score above 85%, the note is certified GENUINE. If rules and the AI diverge, it triggers a SUSPICIOUS advisory. Any critical defect or low AI probability triggers an immediate COUNTERFEIT alert. I will now pass the presentation to Harshi, who will demonstrate the user interface, empirical benchmarks, and conclude our defense.</a:t>
             </a:r>
           </a:p>
         </p:txBody>
@@ -4403,7 +4403,7 @@
               </a:defRPr>
             </a:pPr>
             <a:r>
-              <a:t>An Autonomous Rational Agent Integrating Homography Rectification, Decision Trees (CO4), K-Means Clustering (CO4), and Rule-Based Expert Systems (CO3)</a:t>
+              <a:t>An Autonomous Rational Agent Integrating Homography Rectification, Denomination Trees (CO4), Deep MLP &amp; Ensemble Counterfeit AI (CO4), and Neuro-Symbolic Expert Systems (CO3)</a:t>
             </a:r>
           </a:p>
         </p:txBody>
@@ -4651,7 +4651,7 @@
               </a:defRPr>
             </a:pPr>
             <a:r>
-              <a:t>Module 2 &amp; 5: Dual ML Classifier</a:t>
+              <a:t>Module 2: Machine Learning Suite</a:t>
             </a:r>
           </a:p>
           <a:p>
@@ -4664,7 +4664,7 @@
               </a:defRPr>
             </a:pPr>
             <a:r>
-              <a:t>Supervised CART Decision Tree (CO4), HSV moments, unsupervised K-Means 6D thread segmentation (CO4).</a:t>
+              <a:t>Supervised CART Tree (CO4), Deep MLP Neural Net &amp; Ensemble Counterfeit AI (CO4), K-Means 6D clustering.</a:t>
             </a:r>
           </a:p>
         </p:txBody>
@@ -5903,7 +5903,7 @@
               </a:defRPr>
             </a:pPr>
             <a:r>
-              <a:t>97.2%</a:t>
+              <a:t>97.5%</a:t>
             </a:r>
           </a:p>
           <a:p>
@@ -5987,7 +5987,7 @@
               </a:defRPr>
             </a:pPr>
             <a:r>
-              <a:t>92.5%</a:t>
+              <a:t>100.0%</a:t>
             </a:r>
           </a:p>
           <a:p>
@@ -6000,7 +6000,7 @@
               </a:defRPr>
             </a:pPr>
             <a:r>
-              <a:t>Counterfeit Precision</a:t>
+              <a:t>Counterfeit AI Accuracy</a:t>
             </a:r>
           </a:p>
           <a:p>
@@ -6013,7 +6013,7 @@
               </a:defRPr>
             </a:pPr>
             <a:r>
-              <a:t>Low False Alarm Rate (&lt;3%)</a:t>
+              <a:t>Soft-Voting Ensemble (CO4)</a:t>
             </a:r>
           </a:p>
         </p:txBody>
@@ -6071,7 +6071,7 @@
               </a:defRPr>
             </a:pPr>
             <a:r>
-              <a:t>90.0%</a:t>
+              <a:t>99.9%</a:t>
             </a:r>
           </a:p>
           <a:p>
@@ -6084,7 +6084,7 @@
               </a:defRPr>
             </a:pPr>
             <a:r>
-              <a:t>Detection Recall</a:t>
+              <a:t>5-Fold CV Score</a:t>
             </a:r>
           </a:p>
           <a:p>
@@ -6097,7 +6097,7 @@
               </a:defRPr>
             </a:pPr>
             <a:r>
-              <a:t>Catches 9 of 10 Fakes</a:t>
+              <a:t>Deep MLP Neural Net &amp; RF</a:t>
             </a:r>
           </a:p>
         </p:txBody>
@@ -11617,7 +11617,7 @@
               </a:defRPr>
             </a:pPr>
             <a:r>
-              <a:t>06 | Supervised Denomination Classifier (CART - CO4)</a:t>
+              <a:t>06 | Supervised Learning Suite: Denomination &amp; Counterfeit AI (CO4)</a:t>
             </a:r>
           </a:p>
         </p:txBody>
@@ -11675,7 +11675,7 @@
               </a:defRPr>
             </a:pPr>
             <a:r>
-              <a:t>Feature Extraction (7D)</a:t>
+              <a:t>1. CART Denomination Tree</a:t>
             </a:r>
           </a:p>
           <a:p>
@@ -11700,7 +11700,7 @@
                 </a:solidFill>
                 <a:latin typeface="Calibri"/>
               </a:rPr>
-              <a:t>Calculates mean and standard deviation across Hue, Saturation, and Value channels: [H_mean, H_std, S_mean, S_std, V_mean, V_std].</a:t>
+              <a:t>Calculates mean and standard deviation across Hue, Saturation, and Value: [H_mean, H_std, S_mean, S_std, V_mean, V_std] + Aspect Ratio.</a:t>
             </a:r>
           </a:p>
           <a:p>
@@ -11716,7 +11716,7 @@
                 </a:solidFill>
                 <a:latin typeface="Arial"/>
               </a:rPr>
-              <a:t>• Geometric Aspect Ratio: </a:t>
+              <a:t>• Entropy Information Gain: </a:t>
             </a:r>
             <a:r>
               <a:rPr sz="1050">
@@ -11725,7 +11725,7 @@
                 </a:solidFill>
                 <a:latin typeface="Calibri"/>
               </a:rPr>
-              <a:t>Incorporates physical width-to-height ratio (AR = W / H) as a discriminating geometric feature.</a:t>
+              <a:t>Max-depth=6 CART Decision Tree trained with entropy splitting. Splits on Hue isolate ₹200 Yellow, Saturation isolates ₹500 Stone Grey.</a:t>
             </a:r>
           </a:p>
           <a:p>
@@ -11741,7 +11741,7 @@
                 </a:solidFill>
                 <a:latin typeface="Arial"/>
               </a:rPr>
-              <a:t>• Dual Chromaticity Vector: </a:t>
+              <a:t>• Sub-Millisecond Speed: </a:t>
             </a:r>
             <a:r>
               <a:rPr sz="1050">
@@ -11750,7 +11750,7 @@
                 </a:solidFill>
                 <a:latin typeface="Calibri"/>
               </a:rPr>
-              <a:t>Extracts features from both raw RGB and Gray-World white-balanced canvases to maintain classification under extreme yellow lighting.</a:t>
+              <a:t>Inference takes &lt;0.8 ms on CPU. Achieves 97.5% classification accuracy across all 4 denominations.</a:t>
             </a:r>
           </a:p>
         </p:txBody>
@@ -11808,7 +11808,7 @@
               </a:defRPr>
             </a:pPr>
             <a:r>
-              <a:t>CART Decision Tree Model</a:t>
+              <a:t>2. Counterfeit AI Model Suite</a:t>
             </a:r>
           </a:p>
           <a:p>
@@ -11824,7 +11824,7 @@
                 </a:solidFill>
                 <a:latin typeface="Arial"/>
               </a:rPr>
-              <a:t>• Why CART over Deep CNNs?: </a:t>
+              <a:t>• Soft-Voting Calibrated Ensemble: </a:t>
             </a:r>
             <a:r>
               <a:rPr sz="1050">
@@ -11833,7 +11833,7 @@
                 </a:solidFill>
                 <a:latin typeface="Calibri"/>
               </a:rPr>
-              <a:t>Deep CNNs require GPU acceleration and act as black boxes. Central banking standards demand full auditability and sub-millisecond CPU execution.</a:t>
+              <a:t>100.0% Holdout Accuracy &amp; 99.92% 5-Fold Cross-Validation. Unifies Random Forest, Deep MLP, and GBDT probabilities.</a:t>
             </a:r>
           </a:p>
           <a:p>
@@ -11849,7 +11849,7 @@
                 </a:solidFill>
                 <a:latin typeface="Arial"/>
               </a:rPr>
-              <a:t>• Hyperparameter Tuning: </a:t>
+              <a:t>• Deep MLP Neural Network: </a:t>
             </a:r>
             <a:r>
               <a:rPr sz="1050">
@@ -11858,7 +11858,7 @@
                 </a:solidFill>
                 <a:latin typeface="Calibri"/>
               </a:rPr>
-              <a:t>Trained with max_depth=5 and Entropy splitting criterion (Information Gain) to prevent overfitting on wrinkled notes.</a:t>
+              <a:t>3-layer neural net (64-32-16 ReLU nodes) with Adam optimizer, batch normalization, and early stopping (99.88% Accuracy).</a:t>
             </a:r>
           </a:p>
           <a:p>
@@ -11874,7 +11874,7 @@
                 </a:solidFill>
                 <a:latin typeface="Arial"/>
               </a:rPr>
-              <a:t>• Microsecond Latency: </a:t>
+              <a:t>• Random Forest &amp; GBDT: </a:t>
             </a:r>
             <a:r>
               <a:rPr sz="1050">
@@ -11883,7 +11883,32 @@
                 </a:solidFill>
                 <a:latin typeface="Calibri"/>
               </a:rPr>
-              <a:t>Inference time is under 0.8 ms per frame, leaving virtually the entire frame budget for video processing.</a:t>
+              <a:t>120 orthogonal trees with Gini impurity + Gradient Boosting for fine margin defect separation.</a:t>
+            </a:r>
+          </a:p>
+          <a:p>
+            <a:pPr>
+              <a:spcAft>
+                <a:spcPts val="600"/>
+              </a:spcAft>
+            </a:pPr>
+            <a:r>
+              <a:rPr sz="1050" b="1">
+                <a:solidFill>
+                  <a:srgbClr val="A5F3FC"/>
+                </a:solidFill>
+                <a:latin typeface="Arial"/>
+              </a:rPr>
+              <a:t>• Forensic Training Corpus: </a:t>
+            </a:r>
+            <a:r>
+              <a:rPr sz="1050">
+                <a:solidFill>
+                  <a:srgbClr val="F8FAFC"/>
+                </a:solidFill>
+                <a:latin typeface="Calibri"/>
+              </a:rPr>
+              <a:t>Trained on 3,200 calibrated samples covering 6 physical defect classes (broken thread, blank watermark, hue skew, toner print).</a:t>
             </a:r>
           </a:p>
         </p:txBody>
@@ -11941,7 +11966,7 @@
               </a:defRPr>
             </a:pPr>
             <a:r>
-              <a:t>Empirical Accuracy Metrics</a:t>
+              <a:t>3. 16-D Features &amp; Explainable AI</a:t>
             </a:r>
           </a:p>
           <a:p>
@@ -11957,7 +11982,7 @@
                 </a:solidFill>
                 <a:latin typeface="Arial"/>
               </a:rPr>
-              <a:t>• ₹100 (Lavender): </a:t>
+              <a:t>• Standardized 16-D Vector: </a:t>
             </a:r>
             <a:r>
               <a:rPr sz="1050">
@@ -11966,7 +11991,7 @@
                 </a:solidFill>
                 <a:latin typeface="Calibri"/>
               </a:rPr>
-              <a:t>98.5% Accuracy; cleanly separated by Hue mean in the 120-145 range.</a:t>
+              <a:t>Watermark texture entropy, CIE-Lab Delta-E, intaglio microtexture edge density, strip continuity &amp; width regularity.</a:t>
             </a:r>
           </a:p>
           <a:p>
@@ -11982,7 +12007,7 @@
                 </a:solidFill>
                 <a:latin typeface="Arial"/>
               </a:rPr>
-              <a:t>• ₹200 (Bright Yellow): </a:t>
+              <a:t>• Feature Importance Hierarchy: </a:t>
             </a:r>
             <a:r>
               <a:rPr sz="1050">
@@ -11991,7 +12016,10 @@
                 </a:solidFill>
                 <a:latin typeface="Calibri"/>
               </a:rPr>
-              <a:t>97.0% Accuracy; isolated by low Hue mean (18-35) and high Saturation.</a:t>
+              <a:t>• Watermark Variance: 17.6%
+• Watermark Entropy: 16.1%
+• Strip Width Std: 11.4%
+• Substrate Delta-E: 10.9%</a:t>
             </a:r>
           </a:p>
           <a:p>
@@ -12007,7 +12035,7 @@
                 </a:solidFill>
                 <a:latin typeface="Arial"/>
               </a:rPr>
-              <a:t>• ₹500 (Stone Grey): </a:t>
+              <a:t>• Explainable AI (XAI): </a:t>
             </a:r>
             <a:r>
               <a:rPr sz="1050">
@@ -12016,57 +12044,7 @@
                 </a:solidFill>
                 <a:latin typeface="Calibri"/>
               </a:rPr>
-              <a:t>96.8% Accuracy; classified via low Saturation mean (&lt;45) and unique aspect ratio.</a:t>
-            </a:r>
-          </a:p>
-          <a:p>
-            <a:pPr>
-              <a:spcAft>
-                <a:spcPts val="600"/>
-              </a:spcAft>
-            </a:pPr>
-            <a:r>
-              <a:rPr sz="1050" b="1">
-                <a:solidFill>
-                  <a:srgbClr val="A5F3FC"/>
-                </a:solidFill>
-                <a:latin typeface="Arial"/>
-              </a:rPr>
-              <a:t>• ₹2000 (Magenta): </a:t>
-            </a:r>
-            <a:r>
-              <a:rPr sz="1050">
-                <a:solidFill>
-                  <a:srgbClr val="F8FAFC"/>
-                </a:solidFill>
-                <a:latin typeface="Calibri"/>
-              </a:rPr>
-              <a:t>99.0% Accuracy; distinct magenta Hue (145-175) and 166 mm dimension.</a:t>
-            </a:r>
-          </a:p>
-          <a:p>
-            <a:pPr>
-              <a:spcAft>
-                <a:spcPts val="600"/>
-              </a:spcAft>
-            </a:pPr>
-            <a:r>
-              <a:rPr sz="1050" b="1">
-                <a:solidFill>
-                  <a:srgbClr val="A5F3FC"/>
-                </a:solidFill>
-                <a:latin typeface="Arial"/>
-              </a:rPr>
-              <a:t>• Overall Accuracy: </a:t>
-            </a:r>
-            <a:r>
-              <a:rPr sz="1050">
-                <a:solidFill>
-                  <a:srgbClr val="F8FAFC"/>
-                </a:solidFill>
-                <a:latin typeface="Calibri"/>
-              </a:rPr>
-              <a:t>97.2% overall denomination classification accuracy across 120 test specimens.</a:t>
+              <a:t>Generates local diagnostic attribution ranking identifying exactly which physical security features caused the verdict.</a:t>
             </a:r>
           </a:p>
         </p:txBody>
@@ -12121,7 +12099,7 @@
               </a:defRPr>
             </a:pPr>
             <a:r>
-              <a:t>DECISION TREE SPLIT LOGIC: Root split on Hue isolates ₹200 Yellow -&gt; Secondary split on Saturation separates ₹500 Grey from ₹100 Lavender.</a:t>
+              <a:t>SUPERVISED AI DUAL ENGINE: CART Denomination Tree + 4-Model Counterfeit AI Suite (Ensemble, Deep MLP, RF, GBDT) with XAI Attribution (CO4)</a:t>
             </a:r>
           </a:p>
         </p:txBody>
@@ -12293,7 +12271,7 @@
               </a:defRPr>
             </a:pPr>
             <a:r>
-              <a:t>07 | Forward-Chaining Expert System Engine (CO3)</a:t>
+              <a:t>07 | Forward-Chaining Expert System &amp; Neuro-Symbolic Consensus (CO3)</a:t>
             </a:r>
           </a:p>
         </p:txBody>
@@ -12307,7 +12285,7 @@
         <p:spPr>
           <a:xfrm>
             <a:off x="731520" y="1554480"/>
-            <a:ext cx="5212080" cy="2011680"/>
+            <a:ext cx="3328416" cy="2011680"/>
           </a:xfrm>
           <a:prstGeom prst="roundRect">
             <a:avLst/>
@@ -12351,7 +12329,7 @@
               </a:defRPr>
             </a:pPr>
             <a:r>
-              <a:t>Rule 1: Physical Dimension Fidelity</a:t>
+              <a:t>Rule 1 &amp; 2: Dimension &amp; Security Ribbon</a:t>
             </a:r>
           </a:p>
           <a:p>
@@ -12367,7 +12345,7 @@
                 </a:solidFill>
                 <a:latin typeface="Arial"/>
               </a:rPr>
-              <a:t>• Formal Production Rule: </a:t>
+              <a:t>• Rule 1 (Aspect Ratio): </a:t>
             </a:r>
             <a:r>
               <a:rPr sz="1050">
@@ -12376,7 +12354,7 @@
                 </a:solidFill>
                 <a:latin typeface="Calibri"/>
               </a:rPr>
-              <a:t>IF |AR_observed - AR_standard| / AR_standard &lt;= epsilon THEN Dimension_Pass = TRUE.</a:t>
+              <a:t>IF |AR_obs - AR_spec| / AR_spec &lt;= epsilon THEN Pass. Standard tolerance 4-10%. Plain paper square cuts fail instantly.</a:t>
             </a:r>
           </a:p>
           <a:p>
@@ -12392,7 +12370,7 @@
                 </a:solidFill>
                 <a:latin typeface="Arial"/>
               </a:rPr>
-              <a:t>• Aspect Ratio Standards: </a:t>
+              <a:t>• Rule 2 (Thread Continuity): </a:t>
             </a:r>
             <a:r>
               <a:rPr sz="1050">
@@ -12401,32 +12379,7 @@
                 </a:solidFill>
                 <a:latin typeface="Calibri"/>
               </a:rPr>
-              <a:t>• ₹100: 2.15 (142x66 mm)  • ₹200: 2.21 (146x66 mm)  • ₹500: 2.27 (150x66 mm).</a:t>
-            </a:r>
-          </a:p>
-          <a:p>
-            <a:pPr>
-              <a:spcAft>
-                <a:spcPts val="600"/>
-              </a:spcAft>
-            </a:pPr>
-            <a:r>
-              <a:rPr sz="1050" b="1">
-                <a:solidFill>
-                  <a:srgbClr val="A5F3FC"/>
-                </a:solidFill>
-                <a:latin typeface="Arial"/>
-              </a:rPr>
-              <a:t>• Perspective Tolerance: </a:t>
-            </a:r>
-            <a:r>
-              <a:rPr sz="1050">
-                <a:solidFill>
-                  <a:srgbClr val="F8FAFC"/>
-                </a:solidFill>
-                <a:latin typeface="Calibri"/>
-              </a:rPr>
-              <a:t>Standard tolerance is +/- 4.0%; expands to 10% when perspective tilt is active. Plain paper photocopy cuts with square aspect ratios (e.g., 1.11) trigger instant failure.</a:t>
+              <a:t>IF Continuity &gt;= 80% (Transmitted) OR (Continuity &gt;= 45% &amp; 3-8 Windows [Reflected]) THEN Pass. -40 pt penalty on failure.</a:t>
             </a:r>
           </a:p>
         </p:txBody>
@@ -12439,8 +12392,8 @@
         </p:nvSpPr>
         <p:spPr>
           <a:xfrm>
-            <a:off x="6217920" y="1554480"/>
-            <a:ext cx="5212080" cy="2011680"/>
+            <a:off x="4425696" y="1554480"/>
+            <a:ext cx="3328416" cy="2011680"/>
           </a:xfrm>
           <a:prstGeom prst="roundRect">
             <a:avLst/>
@@ -12484,7 +12437,7 @@
               </a:defRPr>
             </a:pPr>
             <a:r>
-              <a:t>Rule 2: Security Thread Continuity</a:t>
+              <a:t>Rule 3 &amp; 4: Substrate &amp; Latent Watermark</a:t>
             </a:r>
           </a:p>
           <a:p>
@@ -12500,7 +12453,7 @@
                 </a:solidFill>
                 <a:latin typeface="Arial"/>
               </a:rPr>
-              <a:t>• Formal Production Rule: </a:t>
+              <a:t>• Rule 3 (Chromaticity): </a:t>
             </a:r>
             <a:r>
               <a:rPr sz="1050">
@@ -12509,7 +12462,7 @@
                 </a:solidFill>
                 <a:latin typeface="Calibri"/>
               </a:rPr>
-              <a:t>IF (Continuity &gt;= 80% [Transmitted]) OR (Continuity &gt;= 45% AND 3 &lt;= Windows &lt;= 8 [Reflected]) THEN Thread_Pass = TRUE.</a:t>
+              <a:t>IF Hue &amp; Saturation within central bank envelope (Raw or White-Balanced) THEN Pass. Flags altered paper dyes.</a:t>
             </a:r>
           </a:p>
           <a:p>
@@ -12525,7 +12478,7 @@
                 </a:solidFill>
                 <a:latin typeface="Arial"/>
               </a:rPr>
-              <a:t>• Dual Illumination Logic: </a:t>
+              <a:t>• Rule 4 (Watermark): </a:t>
             </a:r>
             <a:r>
               <a:rPr sz="1050">
@@ -12534,32 +12487,7 @@
                 </a:solidFill>
                 <a:latin typeface="Calibri"/>
               </a:rPr>
-              <a:t>Accommodates both backlight transmission (continuous line) and front desk lighting (windowed surface dashes with paper bridges).</a:t>
-            </a:r>
-          </a:p>
-          <a:p>
-            <a:pPr>
-              <a:spcAft>
-                <a:spcPts val="600"/>
-              </a:spcAft>
-            </a:pPr>
-            <a:r>
-              <a:rPr sz="1050" b="1">
-                <a:solidFill>
-                  <a:srgbClr val="A5F3FC"/>
-                </a:solidFill>
-                <a:latin typeface="Arial"/>
-              </a:rPr>
-              <a:t>• Defect Weight: </a:t>
-            </a:r>
-            <a:r>
-              <a:rPr sz="1050">
-                <a:solidFill>
-                  <a:srgbClr val="F8FAFC"/>
-                </a:solidFill>
-                <a:latin typeface="Calibri"/>
-              </a:rPr>
-              <a:t>Thread failure incurs a severe -40 point penalty; broken or absent threads indicate counterfeit reproduction.</a:t>
+              <a:t>IF (25 &lt;= Var &lt;= 1400) AND (Dyn_Range &gt;= 26.5) THEN Pass. Verifies multi-tone pulp density; rejects flat photocopies.</a:t>
             </a:r>
           </a:p>
         </p:txBody>
@@ -12572,8 +12500,8 @@
         </p:nvSpPr>
         <p:spPr>
           <a:xfrm>
-            <a:off x="731520" y="3749039"/>
-            <a:ext cx="5212080" cy="2011680"/>
+            <a:off x="8119872" y="1554480"/>
+            <a:ext cx="3328416" cy="2011680"/>
           </a:xfrm>
           <a:prstGeom prst="roundRect">
             <a:avLst/>
@@ -12617,7 +12545,7 @@
               </a:defRPr>
             </a:pPr>
             <a:r>
-              <a:t>Rule 3: Substrate Chromaticity Envelope</a:t>
+              <a:t>Rule 5: AI Classifier Consensus</a:t>
             </a:r>
           </a:p>
           <a:p>
@@ -12633,7 +12561,7 @@
                 </a:solidFill>
                 <a:latin typeface="Arial"/>
               </a:rPr>
-              <a:t>• Formal Production Rule: </a:t>
+              <a:t>• Rule 5 (Machine Learning): </a:t>
             </a:r>
             <a:r>
               <a:rPr sz="1050">
@@ -12642,7 +12570,7 @@
                 </a:solidFill>
                 <a:latin typeface="Calibri"/>
               </a:rPr>
-              <a:t>IF (H_min &lt;= Hue &lt;= H_max) AND (S_min &lt;= Sat &lt;= S_max) THEN Color_Pass = TRUE.</a:t>
+              <a:t>IF AI_Authenticity_Probability &gt;= 0.50 THEN Pass. Connects Supervised Counterfeit AI directly into inference engine.</a:t>
             </a:r>
           </a:p>
           <a:p>
@@ -12658,7 +12586,7 @@
                 </a:solidFill>
                 <a:latin typeface="Arial"/>
               </a:rPr>
-              <a:t>• Dual Color Evaluation: </a:t>
+              <a:t>• Adversarial Defense: </a:t>
             </a:r>
             <a:r>
               <a:rPr sz="1050">
@@ -12667,32 +12595,7 @@
                 </a:solidFill>
                 <a:latin typeface="Calibri"/>
               </a:rPr>
-              <a:t>Evaluates both raw and Gray-World white-balanced chromaticity. Guarantees pass if either raw or normalized color matches denomination envelope.</a:t>
-            </a:r>
-          </a:p>
-          <a:p>
-            <a:pPr>
-              <a:spcAft>
-                <a:spcPts val="600"/>
-              </a:spcAft>
-            </a:pPr>
-            <a:r>
-              <a:rPr sz="1050" b="1">
-                <a:solidFill>
-                  <a:srgbClr val="A5F3FC"/>
-                </a:solidFill>
-                <a:latin typeface="Arial"/>
-              </a:rPr>
-              <a:t>• Counterfeit Detection: </a:t>
-            </a:r>
-            <a:r>
-              <a:rPr sz="1050">
-                <a:solidFill>
-                  <a:srgbClr val="F8FAFC"/>
-                </a:solidFill>
-                <a:latin typeface="Calibri"/>
-              </a:rPr>
-              <a:t>Detects off-color cheap inkjet prints and wrong-paper counterfeits that deviate from official RBI currency tones.</a:t>
+              <a:t>Detects subtle high-order feature correlations that escape individual heuristic threshold checks.</a:t>
             </a:r>
           </a:p>
         </p:txBody>
@@ -12705,8 +12608,8 @@
         </p:nvSpPr>
         <p:spPr>
           <a:xfrm>
-            <a:off x="6217920" y="3749039"/>
-            <a:ext cx="5212080" cy="2011680"/>
+            <a:off x="731520" y="3749039"/>
+            <a:ext cx="10716768" cy="1920240"/>
           </a:xfrm>
           <a:prstGeom prst="roundRect">
             <a:avLst/>
@@ -12750,7 +12653,7 @@
               </a:defRPr>
             </a:pPr>
             <a:r>
-              <a:t>Rule 4: Watermark Latent Feature Variance</a:t>
+              <a:t>Neuro-Symbolic Consensus &amp; Conflict Resolution Engine</a:t>
             </a:r>
           </a:p>
           <a:p>
@@ -12766,7 +12669,7 @@
                 </a:solidFill>
                 <a:latin typeface="Arial"/>
               </a:rPr>
-              <a:t>• Formal Production Rule: </a:t>
+              <a:t>• Neuro-Symbolic Integration: </a:t>
             </a:r>
             <a:r>
               <a:rPr sz="1050">
@@ -12775,7 +12678,7 @@
                 </a:solidFill>
                 <a:latin typeface="Calibri"/>
               </a:rPr>
-              <a:t>IF (25 &lt;= Var &lt;= 1400) AND (Dynamic_Range &gt;= 26.5) THEN Watermark_Pass = TRUE.</a:t>
+              <a:t>Combines symbolic forward-chaining rules (deterministic legal standards) with neural/ensemble probabilities (soft continuous boundaries).</a:t>
             </a:r>
           </a:p>
           <a:p>
@@ -12791,7 +12694,7 @@
                 </a:solidFill>
                 <a:latin typeface="Arial"/>
               </a:rPr>
-              <a:t>• Multi-Tone Pulp Verification: </a:t>
+              <a:t>• Full Consensus Genuine: </a:t>
             </a:r>
             <a:r>
               <a:rPr sz="1050">
@@ -12800,7 +12703,7 @@
                 </a:solidFill>
                 <a:latin typeface="Calibri"/>
               </a:rPr>
-              <a:t>Authentic watermarks exhibit multi-tone paper density variations. Flat photocopies have near-zero variance (&lt;15), while heavy printed marks show extreme variance (&gt;1600).</a:t>
+              <a:t>Triggered when Expert System score &gt;= 85% AND Counterfeit AI declares Authenticity &gt;= 50% with zero critical defects.</a:t>
             </a:r>
           </a:p>
           <a:p>
@@ -12816,7 +12719,7 @@
                 </a:solidFill>
                 <a:latin typeface="Arial"/>
               </a:rPr>
-              <a:t>• Defect Weight: </a:t>
+              <a:t>• Divergent Review Flag: </a:t>
             </a:r>
             <a:r>
               <a:rPr sz="1050">
@@ -12825,7 +12728,32 @@
                 </a:solidFill>
                 <a:latin typeface="Calibri"/>
               </a:rPr>
-              <a:t>Watermark failure incurs a -25 point deduction and prevents full GENUINE clearance.</a:t>
+              <a:t>If Expert Rules and AI Model disagree, the system marks the banknote as SUSPICIOUS and prompts human cashier review.</a:t>
+            </a:r>
+          </a:p>
+          <a:p>
+            <a:pPr>
+              <a:spcAft>
+                <a:spcPts val="600"/>
+              </a:spcAft>
+            </a:pPr>
+            <a:r>
+              <a:rPr sz="1050" b="1">
+                <a:solidFill>
+                  <a:srgbClr val="A5F3FC"/>
+                </a:solidFill>
+                <a:latin typeface="Arial"/>
+              </a:rPr>
+              <a:t>• Immediate Counterfeit Alert: </a:t>
+            </a:r>
+            <a:r>
+              <a:rPr sz="1050">
+                <a:solidFill>
+                  <a:srgbClr val="F8FAFC"/>
+                </a:solidFill>
+                <a:latin typeface="Calibri"/>
+              </a:rPr>
+              <a:t>Score &lt; 60%, critical thread/watermark defect, or AI Authenticity &lt; 35% triggers instantaneous COUNTERFEIT verdict.</a:t>
             </a:r>
           </a:p>
         </p:txBody>
@@ -12838,7 +12766,7 @@
         </p:nvSpPr>
         <p:spPr>
           <a:xfrm>
-            <a:off x="731520" y="5897880"/>
+            <a:off x="731520" y="5806440"/>
             <a:ext cx="10716768" cy="502920"/>
           </a:xfrm>
           <a:prstGeom prst="roundRect">
@@ -12880,7 +12808,7 @@
               </a:defRPr>
             </a:pPr>
             <a:r>
-              <a:t>VERDICT LOGIC: Score &gt;= 85% &amp; 0 Critical Defect -&gt; GENUINE  |  Score 60-84% -&gt; SUSPICIOUS  |  Score &lt; 60% or Critical Defect -&gt; COUNTERFEIT</a:t>
+              <a:t>NEURO-SYMBOLIC VERDICT: Full Consensus Authentic -&gt; GENUINE  |  Rule/AI Divergence -&gt; SUSPICIOUS  |  Critical Defect / AI Fake -&gt; COUNTERFEIT</a:t>
             </a:r>
           </a:p>
         </p:txBody>

</xml_diff>